<commit_message>
Complete Checkpoint 2: all interviews in gap analysis and slide 5; link Trupti's storyboard
- GAP_ANALYSIS.md: Trupti's and Avni's interview evidence in all 6 rows; 2 new implications
- Slides (PDF + PPTX): Trupti and Avni cards on slide 5
- Trupti's reflection: link her storyboard
- Avni's reflection: remove leftover instruction line and stale caveat

Co-Authored-By: Claude Opus 5.5 <noreply@anthropic.com>
</commit_message>
<xml_diff>
--- a/validation/ReturnGuard_Checkpoint2_Slides.pptx
+++ b/validation/ReturnGuard_Checkpoint2_Slides.pptx
@@ -114,12 +114,12 @@
   <p:extLst>
     <p:ext uri="{521415D9-36F7-43E2-AB2F-B90AF26B5E84}">
       <p14:sectionLst xmlns:p14="http://schemas.microsoft.com/office/powerpoint/2010/main">
-        <p14:section name="Recap" id="{14c8874d-46da-b6f2-8941-f210dd189d9b}">
+        <p14:section name="Recap" id="{0c701a58-58a4-0aed-5605-e2f7ff9bc28d}">
           <p14:sldIdLst>
             <p14:sldId id="256"/>
           </p14:sldIdLst>
         </p14:section>
-        <p14:section name="Validation" id="{80610324-cdf0-9f34-88bc-db9ede21b9b2}">
+        <p14:section name="Validation" id="{bd6a9e9c-d910-58a1-4f43-2b2d662294cc}">
           <p14:sldIdLst>
             <p14:sldId id="257"/>
             <p14:sldId id="258"/>
@@ -127,12 +127,12 @@
             <p14:sldId id="260"/>
           </p14:sldIdLst>
         </p14:section>
-        <p14:section name="Design" id="{66164dd0-a84b-94e5-8d15-ecee19f5347f}">
+        <p14:section name="Design" id="{e82af9f3-3947-fb3d-6d49-76c6cf077edf}">
           <p14:sldIdLst>
             <p14:sldId id="261"/>
           </p14:sldIdLst>
         </p14:section>
-        <p14:section name="Next" id="{fd70d9e4-47a1-a67a-2f6f-80e524beb84d}">
+        <p14:section name="Next" id="{b706d996-3d77-5365-cf27-0f79ef1923e1}">
           <p14:sldIdLst>
             <p14:sldId id="262"/>
             <p14:sldId id="263"/>
@@ -894,7 +894,7 @@
           <a:p>
             <a:r>
               <a:rPr lang="en-US" dirty="0"/>
-              <a:t>About 1 to 1.5 minutes; each member reports their own interviews. Aditya: a customer who shops weekly and a retail associate with two years of returns experience. Both insisted a person has the final say. The customer trusted "100%" less, not more, and asked for a way to appeal. The associate warned that escalating every uncertain case would erase the time savings, and asked for overrides to be tracked. Sharayu: a customer and an e-commerce support specialist. The customer drew the line clearly: AI can recommend, but humans decide a "no"; they also raised bias in profiling "high-risk" customers. The specialist already splits objective denials (one person) from condition-based ones (team lead), and warned that fast AI turns the reviewer into a validator who may rubber-stamp. Trupti and Avni: add your top finding here. The three gaps at the bottom are the theoretical reading: trust calibration, attention, and meta-coordination.</a:t>
+              <a:t>About 1 to 1.5 minutes; each member reports their own interviews. Aditya: a customer who shops weekly and a retail associate with two years of returns experience. Both insisted a person has the final say. The customer trusted "100%" less, not more, and asked for a way to appeal. The associate warned that escalating every uncertain case would erase the time savings, and asked for overrides to be tracked. Sharayu: a customer and an e-commerce support specialist. The customer drew the line clearly: AI can recommend, but humans decide a "no"; they also raised bias in profiling "high-risk" customers. The specialist already splits objective denials (one person) from condition-based ones (team lead), and warned that fast AI turns the reviewer into a validator who may rubber-stamp. Trupti: a weekly online shopper and a warehouse returns associate. The customer drew the line — the AI can say yes, only a person says no — and wanted to know who decided. The associate refuses to sign denials they did not really review, and warned that a holiday escalation flood would put them back to doing everything by hand. Avni: short-form interviews with a customer and a campus bookstore associate. The customer called the concept fair and wants identical cases treated identically; the associate said percentages make people lazy and would check the policy with a shift lead before acting on any AI denial. The three gaps at the bottom are the theoretical reading: trust calibration, attention, and meta-coordination.</a:t>
             </a:r>
             <a:endParaRPr lang="en-US" dirty="0"/>
           </a:p>
@@ -6688,7 +6688,7 @@
                 <a:ea typeface="Calibri" pitchFamily="34" charset="-122"/>
                 <a:cs typeface="Calibri" pitchFamily="34" charset="-120"/>
               </a:rPr>
-              <a:t>Trupti · [2 interviews]</a:t>
+              <a:t>Trupti · customer + returns associate</a:t>
             </a:r>
             <a:endParaRPr lang="en-US" sz="1500" dirty="0"/>
           </a:p>
@@ -6702,13 +6702,33 @@
             <a:r>
               <a:rPr lang="en-US" sz="1300" dirty="0">
                 <a:solidFill>
-                  <a:schemeClr val="tx2"/>
+                  <a:schemeClr val="tx1"/>
                 </a:solidFill>
                 <a:latin typeface="Calibri" pitchFamily="34" charset="0"/>
                 <a:ea typeface="Calibri" pitchFamily="34" charset="-122"/>
                 <a:cs typeface="Calibri" pitchFamily="34" charset="-120"/>
               </a:rPr>
-              <a:t>[Top finding and one quote]</a:t>
+              <a:t>"The AI can say yes. Only a person gets to say no."</a:t>
+            </a:r>
+            <a:endParaRPr lang="en-US" sz="1500" dirty="0"/>
+          </a:p>
+          <a:p>
+            <a:pPr indent="0" marL="0">
+              <a:spcAft>
+                <a:spcPts val="500"/>
+              </a:spcAft>
+              <a:buNone/>
+            </a:pPr>
+            <a:r>
+              <a:rPr lang="en-US" sz="1300" dirty="0">
+                <a:solidFill>
+                  <a:schemeClr val="tx1"/>
+                </a:solidFill>
+                <a:latin typeface="Calibri" pitchFamily="34" charset="0"/>
+                <a:ea typeface="Calibri" pitchFamily="34" charset="-122"/>
+                <a:cs typeface="Calibri" pitchFamily="34" charset="-120"/>
+              </a:rPr>
+              <a:t>"If my name is on the denial, I need to have actually looked."</a:t>
             </a:r>
             <a:endParaRPr lang="en-US" sz="1500" dirty="0"/>
           </a:p>
@@ -6777,7 +6797,7 @@
                 <a:ea typeface="Calibri" pitchFamily="34" charset="-122"/>
                 <a:cs typeface="Calibri" pitchFamily="34" charset="-120"/>
               </a:rPr>
-              <a:t>Avni · [2 interviews]</a:t>
+              <a:t>Avni · customer + bookstore associate</a:t>
             </a:r>
             <a:endParaRPr lang="en-US" sz="1500" dirty="0"/>
           </a:p>
@@ -6791,13 +6811,33 @@
             <a:r>
               <a:rPr lang="en-US" sz="1300" dirty="0">
                 <a:solidFill>
-                  <a:schemeClr val="tx2"/>
+                  <a:schemeClr val="tx1"/>
                 </a:solidFill>
                 <a:latin typeface="Calibri" pitchFamily="34" charset="0"/>
                 <a:ea typeface="Calibri" pitchFamily="34" charset="-122"/>
                 <a:cs typeface="Calibri" pitchFamily="34" charset="-120"/>
               </a:rPr>
-              <a:t>[Top finding and one quote]</a:t>
+              <a:t>"Percentages can make people lazy and trick them into hitting 'approve' without actually looking."</a:t>
+            </a:r>
+            <a:endParaRPr lang="en-US" sz="1500" dirty="0"/>
+          </a:p>
+          <a:p>
+            <a:pPr indent="0" marL="0">
+              <a:spcAft>
+                <a:spcPts val="500"/>
+              </a:spcAft>
+              <a:buNone/>
+            </a:pPr>
+            <a:r>
+              <a:rPr lang="en-US" sz="1300" dirty="0">
+                <a:solidFill>
+                  <a:schemeClr val="tx1"/>
+                </a:solidFill>
+                <a:latin typeface="Calibri" pitchFamily="34" charset="0"/>
+                <a:ea typeface="Calibri" pitchFamily="34" charset="-122"/>
+                <a:cs typeface="Calibri" pitchFamily="34" charset="-120"/>
+              </a:rPr>
+              <a:t>Would check the policy and show their shift lead before any AI denial.</a:t>
             </a:r>
             <a:endParaRPr lang="en-US" sz="1500" dirty="0"/>
           </a:p>

</xml_diff>